<commit_message>
Overview deck: rebuild with Super-Cube® company property and image alt text
</commit_message>
<xml_diff>
--- a/public/downloads/super-cube-overview.pptx
+++ b/public/downloads/super-cube-overview.pptx
@@ -1856,7 +1856,7 @@
       </p:grpSpPr>
       <p:pic>
         <p:nvPicPr>
-          <p:cNvPr id="2" name="Image 0" descr="/workspaces/super-cube-website/scripts/.pptx-assets/rainbow-hairline.png">    </p:cNvPr>
+          <p:cNvPr id="2" name="Image 0" descr="Decorative rainbow line">    </p:cNvPr>
           <p:cNvPicPr>
             <a:picLocks noChangeAspect="1"/>
           </p:cNvPicPr>
@@ -1880,7 +1880,7 @@
       </p:pic>
       <p:pic>
         <p:nvPicPr>
-          <p:cNvPr id="3" name="Image 1" descr="/workspaces/super-cube-website/scripts/.pptx-assets/logo-transparent.png">    </p:cNvPr>
+          <p:cNvPr id="3" name="Image 1" descr="Super-Cube® logo">    </p:cNvPr>
           <p:cNvPicPr>
             <a:picLocks noChangeAspect="1"/>
           </p:cNvPicPr>
@@ -2741,7 +2741,7 @@
       </p:grpSpPr>
       <p:pic>
         <p:nvPicPr>
-          <p:cNvPr id="2" name="Image 0" descr="/workspaces/super-cube-website/scripts/.pptx-assets/rainbow-hairline.png">    </p:cNvPr>
+          <p:cNvPr id="2" name="Image 0" descr="Decorative rainbow line">    </p:cNvPr>
           <p:cNvPicPr>
             <a:picLocks noChangeAspect="1"/>
           </p:cNvPicPr>
@@ -2765,7 +2765,7 @@
       </p:pic>
       <p:pic>
         <p:nvPicPr>
-          <p:cNvPr id="3" name="Image 1" descr="/workspaces/super-cube-website/scripts/.pptx-assets/logo-transparent.png">    </p:cNvPr>
+          <p:cNvPr id="3" name="Image 1" descr="Super-Cube® logo">    </p:cNvPr>
           <p:cNvPicPr>
             <a:picLocks noChangeAspect="1"/>
           </p:cNvPicPr>
@@ -3824,7 +3824,7 @@
       </p:grpSpPr>
       <p:pic>
         <p:nvPicPr>
-          <p:cNvPr id="2" name="Image 0" descr="/workspaces/super-cube-website/scripts/.pptx-assets/rainbow-hairline.png">    </p:cNvPr>
+          <p:cNvPr id="2" name="Image 0" descr="Decorative rainbow line">    </p:cNvPr>
           <p:cNvPicPr>
             <a:picLocks noChangeAspect="1"/>
           </p:cNvPicPr>
@@ -3848,7 +3848,7 @@
       </p:pic>
       <p:pic>
         <p:nvPicPr>
-          <p:cNvPr id="3" name="Image 1" descr="/workspaces/super-cube-website/scripts/.pptx-assets/logo-transparent.png">    </p:cNvPr>
+          <p:cNvPr id="3" name="Image 1" descr="Super-Cube® logo">    </p:cNvPr>
           <p:cNvPicPr>
             <a:picLocks noChangeAspect="1"/>
           </p:cNvPicPr>
@@ -4950,7 +4950,7 @@
       </p:grpSpPr>
       <p:pic>
         <p:nvPicPr>
-          <p:cNvPr id="2" name="Image 0" descr="/workspaces/super-cube-website/scripts/.pptx-assets/rainbow-hairline.png">    </p:cNvPr>
+          <p:cNvPr id="2" name="Image 0" descr="Decorative rainbow line">    </p:cNvPr>
           <p:cNvPicPr>
             <a:picLocks noChangeAspect="1"/>
           </p:cNvPicPr>
@@ -4974,7 +4974,7 @@
       </p:pic>
       <p:pic>
         <p:nvPicPr>
-          <p:cNvPr id="3" name="Image 1" descr="/workspaces/super-cube-website/scripts/.pptx-assets/logo-transparent.png">    </p:cNvPr>
+          <p:cNvPr id="3" name="Image 1" descr="Super-Cube® logo">    </p:cNvPr>
           <p:cNvPicPr>
             <a:picLocks noChangeAspect="1"/>
           </p:cNvPicPr>
@@ -5980,7 +5980,7 @@
       </p:grpSpPr>
       <p:pic>
         <p:nvPicPr>
-          <p:cNvPr id="2" name="Image 0" descr="/workspaces/super-cube-website/scripts/.pptx-assets/rainbow-hairline.png">    </p:cNvPr>
+          <p:cNvPr id="2" name="Image 0" descr="Decorative rainbow line">    </p:cNvPr>
           <p:cNvPicPr>
             <a:picLocks noChangeAspect="1"/>
           </p:cNvPicPr>
@@ -6004,7 +6004,7 @@
       </p:pic>
       <p:pic>
         <p:nvPicPr>
-          <p:cNvPr id="3" name="Image 1" descr="/workspaces/super-cube-website/scripts/.pptx-assets/logo-transparent.png">    </p:cNvPr>
+          <p:cNvPr id="3" name="Image 1" descr="Super-Cube® logo">    </p:cNvPr>
           <p:cNvPicPr>
             <a:picLocks noChangeAspect="1"/>
           </p:cNvPicPr>
@@ -6789,7 +6789,7 @@
       </p:grpSpPr>
       <p:pic>
         <p:nvPicPr>
-          <p:cNvPr id="2" name="Image 0" descr="/workspaces/super-cube-website/scripts/.pptx-assets/rainbow-hairline.png">    </p:cNvPr>
+          <p:cNvPr id="2" name="Image 0" descr="Decorative rainbow line">    </p:cNvPr>
           <p:cNvPicPr>
             <a:picLocks noChangeAspect="1"/>
           </p:cNvPicPr>
@@ -6813,7 +6813,7 @@
       </p:pic>
       <p:pic>
         <p:nvPicPr>
-          <p:cNvPr id="3" name="Image 1" descr="/workspaces/super-cube-website/scripts/.pptx-assets/logo-transparent.png">    </p:cNvPr>
+          <p:cNvPr id="3" name="Image 1" descr="Super-Cube® logo">    </p:cNvPr>
           <p:cNvPicPr>
             <a:picLocks noChangeAspect="1"/>
           </p:cNvPicPr>
@@ -8537,7 +8537,7 @@
       </p:grpSpPr>
       <p:pic>
         <p:nvPicPr>
-          <p:cNvPr id="2" name="Image 0" descr="/workspaces/super-cube-website/scripts/.pptx-assets/rainbow-hairline.png">    </p:cNvPr>
+          <p:cNvPr id="2" name="Image 0" descr="Decorative rainbow line">    </p:cNvPr>
           <p:cNvPicPr>
             <a:picLocks noChangeAspect="1"/>
           </p:cNvPicPr>
@@ -8561,7 +8561,7 @@
       </p:pic>
       <p:pic>
         <p:nvPicPr>
-          <p:cNvPr id="3" name="Image 1" descr="/workspaces/super-cube-website/scripts/.pptx-assets/logo-transparent.png">    </p:cNvPr>
+          <p:cNvPr id="3" name="Image 1" descr="Super-Cube® logo">    </p:cNvPr>
           <p:cNvPicPr>
             <a:picLocks noChangeAspect="1"/>
           </p:cNvPicPr>
@@ -9576,7 +9576,7 @@
       </p:grpSpPr>
       <p:pic>
         <p:nvPicPr>
-          <p:cNvPr id="2" name="Image 0" descr="/workspaces/super-cube-website/scripts/.pptx-assets/rainbow-hairline.png">    </p:cNvPr>
+          <p:cNvPr id="2" name="Image 0" descr="Decorative rainbow line">    </p:cNvPr>
           <p:cNvPicPr>
             <a:picLocks noChangeAspect="1"/>
           </p:cNvPicPr>
@@ -9600,7 +9600,7 @@
       </p:pic>
       <p:pic>
         <p:nvPicPr>
-          <p:cNvPr id="3" name="Image 1" descr="/workspaces/super-cube-website/scripts/.pptx-assets/logo-transparent.png">    </p:cNvPr>
+          <p:cNvPr id="3" name="Image 1" descr="Super-Cube® logo">    </p:cNvPr>
           <p:cNvPicPr>
             <a:picLocks noChangeAspect="1"/>
           </p:cNvPicPr>
@@ -11043,7 +11043,7 @@
       </p:grpSpPr>
       <p:pic>
         <p:nvPicPr>
-          <p:cNvPr id="2" name="Image 0" descr="/workspaces/super-cube-website/scripts/.pptx-assets/rainbow-hairline.png">    </p:cNvPr>
+          <p:cNvPr id="2" name="Image 0" descr="Decorative rainbow line">    </p:cNvPr>
           <p:cNvPicPr>
             <a:picLocks noChangeAspect="1"/>
           </p:cNvPicPr>
@@ -11067,7 +11067,7 @@
       </p:pic>
       <p:pic>
         <p:nvPicPr>
-          <p:cNvPr id="3" name="Image 1" descr="/workspaces/super-cube-website/scripts/.pptx-assets/logo-transparent.png">    </p:cNvPr>
+          <p:cNvPr id="3" name="Image 1" descr="Super-Cube® logo">    </p:cNvPr>
           <p:cNvPicPr>
             <a:picLocks noChangeAspect="1"/>
           </p:cNvPicPr>
@@ -11961,7 +11961,7 @@
       </p:grpSpPr>
       <p:pic>
         <p:nvPicPr>
-          <p:cNvPr id="2" name="Image 0" descr="/workspaces/super-cube-website/scripts/.pptx-assets/rainbow-hairline.png">    </p:cNvPr>
+          <p:cNvPr id="2" name="Image 0" descr="Decorative rainbow line">    </p:cNvPr>
           <p:cNvPicPr>
             <a:picLocks noChangeAspect="1"/>
           </p:cNvPicPr>
@@ -11985,7 +11985,7 @@
       </p:pic>
       <p:pic>
         <p:nvPicPr>
-          <p:cNvPr id="3" name="Image 1" descr="/workspaces/super-cube-website/scripts/.pptx-assets/logo-transparent.png">    </p:cNvPr>
+          <p:cNvPr id="3" name="Image 1" descr="Super-Cube® logo">    </p:cNvPr>
           <p:cNvPicPr>
             <a:picLocks noChangeAspect="1"/>
           </p:cNvPicPr>
@@ -13278,7 +13278,7 @@
       </p:grpSpPr>
       <p:pic>
         <p:nvPicPr>
-          <p:cNvPr id="2" name="Image 0" descr="/workspaces/super-cube-website/scripts/.pptx-assets/rainbow-hairline.png">    </p:cNvPr>
+          <p:cNvPr id="2" name="Image 0" descr="Decorative rainbow line">    </p:cNvPr>
           <p:cNvPicPr>
             <a:picLocks noChangeAspect="1"/>
           </p:cNvPicPr>
@@ -13302,7 +13302,7 @@
       </p:pic>
       <p:pic>
         <p:nvPicPr>
-          <p:cNvPr id="3" name="Image 1" descr="/workspaces/super-cube-website/scripts/.pptx-assets/logo-transparent.png">    </p:cNvPr>
+          <p:cNvPr id="3" name="Image 1" descr="Super-Cube® logo">    </p:cNvPr>
           <p:cNvPicPr>
             <a:picLocks noChangeAspect="1"/>
           </p:cNvPicPr>
@@ -14229,7 +14229,7 @@
       </p:grpSpPr>
       <p:pic>
         <p:nvPicPr>
-          <p:cNvPr id="2" name="Image 0" descr="/workspaces/super-cube-website/scripts/.pptx-assets/rainbow-hairline.png">    </p:cNvPr>
+          <p:cNvPr id="2" name="Image 0" descr="Decorative rainbow line">    </p:cNvPr>
           <p:cNvPicPr>
             <a:picLocks noChangeAspect="1"/>
           </p:cNvPicPr>
@@ -14253,7 +14253,7 @@
       </p:pic>
       <p:pic>
         <p:nvPicPr>
-          <p:cNvPr id="3" name="Image 1" descr="/workspaces/super-cube-website/scripts/.pptx-assets/logo-transparent.png">    </p:cNvPr>
+          <p:cNvPr id="3" name="Image 1" descr="Super-Cube® logo">    </p:cNvPr>
           <p:cNvPicPr>
             <a:picLocks noChangeAspect="1"/>
           </p:cNvPicPr>

</xml_diff>

<commit_message>
Overview deck: rebuild with Super-Cube® company property and image alt text (#26)
</commit_message>
<xml_diff>
--- a/public/downloads/super-cube-overview.pptx
+++ b/public/downloads/super-cube-overview.pptx
@@ -1856,7 +1856,7 @@
       </p:grpSpPr>
       <p:pic>
         <p:nvPicPr>
-          <p:cNvPr id="2" name="Image 0" descr="/workspaces/super-cube-website/scripts/.pptx-assets/rainbow-hairline.png">    </p:cNvPr>
+          <p:cNvPr id="2" name="Image 0" descr="Decorative rainbow line">    </p:cNvPr>
           <p:cNvPicPr>
             <a:picLocks noChangeAspect="1"/>
           </p:cNvPicPr>
@@ -1880,7 +1880,7 @@
       </p:pic>
       <p:pic>
         <p:nvPicPr>
-          <p:cNvPr id="3" name="Image 1" descr="/workspaces/super-cube-website/scripts/.pptx-assets/logo-transparent.png">    </p:cNvPr>
+          <p:cNvPr id="3" name="Image 1" descr="Super-Cube® logo">    </p:cNvPr>
           <p:cNvPicPr>
             <a:picLocks noChangeAspect="1"/>
           </p:cNvPicPr>
@@ -2741,7 +2741,7 @@
       </p:grpSpPr>
       <p:pic>
         <p:nvPicPr>
-          <p:cNvPr id="2" name="Image 0" descr="/workspaces/super-cube-website/scripts/.pptx-assets/rainbow-hairline.png">    </p:cNvPr>
+          <p:cNvPr id="2" name="Image 0" descr="Decorative rainbow line">    </p:cNvPr>
           <p:cNvPicPr>
             <a:picLocks noChangeAspect="1"/>
           </p:cNvPicPr>
@@ -2765,7 +2765,7 @@
       </p:pic>
       <p:pic>
         <p:nvPicPr>
-          <p:cNvPr id="3" name="Image 1" descr="/workspaces/super-cube-website/scripts/.pptx-assets/logo-transparent.png">    </p:cNvPr>
+          <p:cNvPr id="3" name="Image 1" descr="Super-Cube® logo">    </p:cNvPr>
           <p:cNvPicPr>
             <a:picLocks noChangeAspect="1"/>
           </p:cNvPicPr>
@@ -3824,7 +3824,7 @@
       </p:grpSpPr>
       <p:pic>
         <p:nvPicPr>
-          <p:cNvPr id="2" name="Image 0" descr="/workspaces/super-cube-website/scripts/.pptx-assets/rainbow-hairline.png">    </p:cNvPr>
+          <p:cNvPr id="2" name="Image 0" descr="Decorative rainbow line">    </p:cNvPr>
           <p:cNvPicPr>
             <a:picLocks noChangeAspect="1"/>
           </p:cNvPicPr>
@@ -3848,7 +3848,7 @@
       </p:pic>
       <p:pic>
         <p:nvPicPr>
-          <p:cNvPr id="3" name="Image 1" descr="/workspaces/super-cube-website/scripts/.pptx-assets/logo-transparent.png">    </p:cNvPr>
+          <p:cNvPr id="3" name="Image 1" descr="Super-Cube® logo">    </p:cNvPr>
           <p:cNvPicPr>
             <a:picLocks noChangeAspect="1"/>
           </p:cNvPicPr>
@@ -4950,7 +4950,7 @@
       </p:grpSpPr>
       <p:pic>
         <p:nvPicPr>
-          <p:cNvPr id="2" name="Image 0" descr="/workspaces/super-cube-website/scripts/.pptx-assets/rainbow-hairline.png">    </p:cNvPr>
+          <p:cNvPr id="2" name="Image 0" descr="Decorative rainbow line">    </p:cNvPr>
           <p:cNvPicPr>
             <a:picLocks noChangeAspect="1"/>
           </p:cNvPicPr>
@@ -4974,7 +4974,7 @@
       </p:pic>
       <p:pic>
         <p:nvPicPr>
-          <p:cNvPr id="3" name="Image 1" descr="/workspaces/super-cube-website/scripts/.pptx-assets/logo-transparent.png">    </p:cNvPr>
+          <p:cNvPr id="3" name="Image 1" descr="Super-Cube® logo">    </p:cNvPr>
           <p:cNvPicPr>
             <a:picLocks noChangeAspect="1"/>
           </p:cNvPicPr>
@@ -5980,7 +5980,7 @@
       </p:grpSpPr>
       <p:pic>
         <p:nvPicPr>
-          <p:cNvPr id="2" name="Image 0" descr="/workspaces/super-cube-website/scripts/.pptx-assets/rainbow-hairline.png">    </p:cNvPr>
+          <p:cNvPr id="2" name="Image 0" descr="Decorative rainbow line">    </p:cNvPr>
           <p:cNvPicPr>
             <a:picLocks noChangeAspect="1"/>
           </p:cNvPicPr>
@@ -6004,7 +6004,7 @@
       </p:pic>
       <p:pic>
         <p:nvPicPr>
-          <p:cNvPr id="3" name="Image 1" descr="/workspaces/super-cube-website/scripts/.pptx-assets/logo-transparent.png">    </p:cNvPr>
+          <p:cNvPr id="3" name="Image 1" descr="Super-Cube® logo">    </p:cNvPr>
           <p:cNvPicPr>
             <a:picLocks noChangeAspect="1"/>
           </p:cNvPicPr>
@@ -6789,7 +6789,7 @@
       </p:grpSpPr>
       <p:pic>
         <p:nvPicPr>
-          <p:cNvPr id="2" name="Image 0" descr="/workspaces/super-cube-website/scripts/.pptx-assets/rainbow-hairline.png">    </p:cNvPr>
+          <p:cNvPr id="2" name="Image 0" descr="Decorative rainbow line">    </p:cNvPr>
           <p:cNvPicPr>
             <a:picLocks noChangeAspect="1"/>
           </p:cNvPicPr>
@@ -6813,7 +6813,7 @@
       </p:pic>
       <p:pic>
         <p:nvPicPr>
-          <p:cNvPr id="3" name="Image 1" descr="/workspaces/super-cube-website/scripts/.pptx-assets/logo-transparent.png">    </p:cNvPr>
+          <p:cNvPr id="3" name="Image 1" descr="Super-Cube® logo">    </p:cNvPr>
           <p:cNvPicPr>
             <a:picLocks noChangeAspect="1"/>
           </p:cNvPicPr>
@@ -8537,7 +8537,7 @@
       </p:grpSpPr>
       <p:pic>
         <p:nvPicPr>
-          <p:cNvPr id="2" name="Image 0" descr="/workspaces/super-cube-website/scripts/.pptx-assets/rainbow-hairline.png">    </p:cNvPr>
+          <p:cNvPr id="2" name="Image 0" descr="Decorative rainbow line">    </p:cNvPr>
           <p:cNvPicPr>
             <a:picLocks noChangeAspect="1"/>
           </p:cNvPicPr>
@@ -8561,7 +8561,7 @@
       </p:pic>
       <p:pic>
         <p:nvPicPr>
-          <p:cNvPr id="3" name="Image 1" descr="/workspaces/super-cube-website/scripts/.pptx-assets/logo-transparent.png">    </p:cNvPr>
+          <p:cNvPr id="3" name="Image 1" descr="Super-Cube® logo">    </p:cNvPr>
           <p:cNvPicPr>
             <a:picLocks noChangeAspect="1"/>
           </p:cNvPicPr>
@@ -9576,7 +9576,7 @@
       </p:grpSpPr>
       <p:pic>
         <p:nvPicPr>
-          <p:cNvPr id="2" name="Image 0" descr="/workspaces/super-cube-website/scripts/.pptx-assets/rainbow-hairline.png">    </p:cNvPr>
+          <p:cNvPr id="2" name="Image 0" descr="Decorative rainbow line">    </p:cNvPr>
           <p:cNvPicPr>
             <a:picLocks noChangeAspect="1"/>
           </p:cNvPicPr>
@@ -9600,7 +9600,7 @@
       </p:pic>
       <p:pic>
         <p:nvPicPr>
-          <p:cNvPr id="3" name="Image 1" descr="/workspaces/super-cube-website/scripts/.pptx-assets/logo-transparent.png">    </p:cNvPr>
+          <p:cNvPr id="3" name="Image 1" descr="Super-Cube® logo">    </p:cNvPr>
           <p:cNvPicPr>
             <a:picLocks noChangeAspect="1"/>
           </p:cNvPicPr>
@@ -11043,7 +11043,7 @@
       </p:grpSpPr>
       <p:pic>
         <p:nvPicPr>
-          <p:cNvPr id="2" name="Image 0" descr="/workspaces/super-cube-website/scripts/.pptx-assets/rainbow-hairline.png">    </p:cNvPr>
+          <p:cNvPr id="2" name="Image 0" descr="Decorative rainbow line">    </p:cNvPr>
           <p:cNvPicPr>
             <a:picLocks noChangeAspect="1"/>
           </p:cNvPicPr>
@@ -11067,7 +11067,7 @@
       </p:pic>
       <p:pic>
         <p:nvPicPr>
-          <p:cNvPr id="3" name="Image 1" descr="/workspaces/super-cube-website/scripts/.pptx-assets/logo-transparent.png">    </p:cNvPr>
+          <p:cNvPr id="3" name="Image 1" descr="Super-Cube® logo">    </p:cNvPr>
           <p:cNvPicPr>
             <a:picLocks noChangeAspect="1"/>
           </p:cNvPicPr>
@@ -11961,7 +11961,7 @@
       </p:grpSpPr>
       <p:pic>
         <p:nvPicPr>
-          <p:cNvPr id="2" name="Image 0" descr="/workspaces/super-cube-website/scripts/.pptx-assets/rainbow-hairline.png">    </p:cNvPr>
+          <p:cNvPr id="2" name="Image 0" descr="Decorative rainbow line">    </p:cNvPr>
           <p:cNvPicPr>
             <a:picLocks noChangeAspect="1"/>
           </p:cNvPicPr>
@@ -11985,7 +11985,7 @@
       </p:pic>
       <p:pic>
         <p:nvPicPr>
-          <p:cNvPr id="3" name="Image 1" descr="/workspaces/super-cube-website/scripts/.pptx-assets/logo-transparent.png">    </p:cNvPr>
+          <p:cNvPr id="3" name="Image 1" descr="Super-Cube® logo">    </p:cNvPr>
           <p:cNvPicPr>
             <a:picLocks noChangeAspect="1"/>
           </p:cNvPicPr>
@@ -13278,7 +13278,7 @@
       </p:grpSpPr>
       <p:pic>
         <p:nvPicPr>
-          <p:cNvPr id="2" name="Image 0" descr="/workspaces/super-cube-website/scripts/.pptx-assets/rainbow-hairline.png">    </p:cNvPr>
+          <p:cNvPr id="2" name="Image 0" descr="Decorative rainbow line">    </p:cNvPr>
           <p:cNvPicPr>
             <a:picLocks noChangeAspect="1"/>
           </p:cNvPicPr>
@@ -13302,7 +13302,7 @@
       </p:pic>
       <p:pic>
         <p:nvPicPr>
-          <p:cNvPr id="3" name="Image 1" descr="/workspaces/super-cube-website/scripts/.pptx-assets/logo-transparent.png">    </p:cNvPr>
+          <p:cNvPr id="3" name="Image 1" descr="Super-Cube® logo">    </p:cNvPr>
           <p:cNvPicPr>
             <a:picLocks noChangeAspect="1"/>
           </p:cNvPicPr>
@@ -14229,7 +14229,7 @@
       </p:grpSpPr>
       <p:pic>
         <p:nvPicPr>
-          <p:cNvPr id="2" name="Image 0" descr="/workspaces/super-cube-website/scripts/.pptx-assets/rainbow-hairline.png">    </p:cNvPr>
+          <p:cNvPr id="2" name="Image 0" descr="Decorative rainbow line">    </p:cNvPr>
           <p:cNvPicPr>
             <a:picLocks noChangeAspect="1"/>
           </p:cNvPicPr>
@@ -14253,7 +14253,7 @@
       </p:pic>
       <p:pic>
         <p:nvPicPr>
-          <p:cNvPr id="3" name="Image 1" descr="/workspaces/super-cube-website/scripts/.pptx-assets/logo-transparent.png">    </p:cNvPr>
+          <p:cNvPr id="3" name="Image 1" descr="Super-Cube® logo">    </p:cNvPr>
           <p:cNvPicPr>
             <a:picLocks noChangeAspect="1"/>
           </p:cNvPicPr>

</xml_diff>

<commit_message>
Remove case-company name; cite the thesis as 2020 (degree 2021)
- Research highlight, /research titles, /media citations, abstract and the
  company profile now describe the case as an African FMCG business network.
- JCM paper file renamed without the company name; permanent redirect from the
  old URL so existing links keep working.
- Thesis cited as 2020 (December 2020); degree/graduation stays 2021.
- Company profile PDF and overview deck regenerated; free book rebuilt with the
  thesis-year wording (67 pages).
</commit_message>
<xml_diff>
--- a/public/downloads/super-cube-overview.pptx
+++ b/public/downloads/super-cube-overview.pptx
@@ -2559,7 +2559,7 @@
                 <a:ea typeface="Calibri" pitchFamily="34" charset="-122"/>
                 <a:cs typeface="Calibri" pitchFamily="34" charset="-120"/>
               </a:rPr>
-              <a:t>Craig Ross Muller  ·  UKZN DBA 2020  ·  Schools · Corporate L&amp;D · Coaches</a:t>
+              <a:t>Craig Ross Muller  ·  UKZN DBA 2021  ·  Schools · Corporate L&amp;D · Coaches</a:t>
             </a:r>
             <a:endParaRPr lang="en-US" sz="1300" dirty="0"/>
           </a:p>
@@ -11273,7 +11273,7 @@
                 <a:ea typeface="Calibri" pitchFamily="34" charset="-122"/>
                 <a:cs typeface="Calibri" pitchFamily="34" charset="-120"/>
               </a:rPr>
-              <a:t>UKZN · DBA · 2020</a:t>
+              <a:t>UKZN · DBA thesis · 2020</a:t>
             </a:r>
             <a:endParaRPr lang="en-US" sz="2200" dirty="0"/>
           </a:p>
@@ -11312,7 +11312,7 @@
                 <a:ea typeface="Calibri" pitchFamily="34" charset="-122"/>
                 <a:cs typeface="Calibri" pitchFamily="34" charset="-120"/>
               </a:rPr>
-              <a:t>A Leadership Skills Development Model for the Kwaden Group: A Case Study of an African FMCG Business-Network (Muller, C. R.).</a:t>
+              <a:t>A leadership skills development model (Super-Cube®): a case study of an African FMCG business network (Muller, C. R., 2020).</a:t>
             </a:r>
             <a:endParaRPr lang="en-US" sz="1300" dirty="0"/>
           </a:p>

</xml_diff>

<commit_message>
Remove case-company name; cite the thesis as 2020 (degree 2021) (#51)
- Research highlight, /research titles, /media citations, abstract and the
  company profile now describe the case as an African FMCG business network.
- JCM paper file renamed without the company name; permanent redirect from the
  old URL so existing links keep working.
- Thesis cited as 2020 (December 2020); degree/graduation stays 2021.
- Company profile PDF and overview deck regenerated; free book rebuilt with the
  thesis-year wording (67 pages).

Co-authored-by: bigfivefoods <265166842+bigfivefoods@users.noreply.github.com>
</commit_message>
<xml_diff>
--- a/public/downloads/super-cube-overview.pptx
+++ b/public/downloads/super-cube-overview.pptx
@@ -2559,7 +2559,7 @@
                 <a:ea typeface="Calibri" pitchFamily="34" charset="-122"/>
                 <a:cs typeface="Calibri" pitchFamily="34" charset="-120"/>
               </a:rPr>
-              <a:t>Craig Ross Muller  ·  UKZN DBA 2020  ·  Schools · Corporate L&amp;D · Coaches</a:t>
+              <a:t>Craig Ross Muller  ·  UKZN DBA 2021  ·  Schools · Corporate L&amp;D · Coaches</a:t>
             </a:r>
             <a:endParaRPr lang="en-US" sz="1300" dirty="0"/>
           </a:p>
@@ -11273,7 +11273,7 @@
                 <a:ea typeface="Calibri" pitchFamily="34" charset="-122"/>
                 <a:cs typeface="Calibri" pitchFamily="34" charset="-120"/>
               </a:rPr>
-              <a:t>UKZN · DBA · 2020</a:t>
+              <a:t>UKZN · DBA thesis · 2020</a:t>
             </a:r>
             <a:endParaRPr lang="en-US" sz="2200" dirty="0"/>
           </a:p>
@@ -11312,7 +11312,7 @@
                 <a:ea typeface="Calibri" pitchFamily="34" charset="-122"/>
                 <a:cs typeface="Calibri" pitchFamily="34" charset="-120"/>
               </a:rPr>
-              <a:t>A Leadership Skills Development Model for the Kwaden Group: A Case Study of an African FMCG Business-Network (Muller, C. R.).</a:t>
+              <a:t>A leadership skills development model (Super-Cube®): a case study of an African FMCG business network (Muller, C. R., 2020).</a:t>
             </a:r>
             <a:endParaRPr lang="en-US" sz="1300" dirty="0"/>
           </a:p>

</xml_diff>